<commit_message>
Reel Template Packs: #09 carousel follows the carousel rules (slide 2 is a second cover, slide 4 new layout, left-aligned lines, no underline/whiskers, caption in notes); rule added to FRAMEWORK
Co-Authored-By: Claude Opus 5.5 <noreply@anthropic.com>
</commit_message>
<xml_diff>
--- a/automation/reel-template-pack/09-who-its-for/carousel/Template 09 - Who its for - Carousel.pptx
+++ b/automation/reel-template-pack/09-who-its-for/carousel/Template 09 - Who its for - Carousel.pptx
@@ -579,7 +579,7 @@
           <a:lstStyle/>
           <a:p>
             <a:r>
-              <a:t>Slide 2. The everyday problem, no photo needed. Edit the [bracket] line.</a:t>
+              <a:t>Slide 2. Second hook: Instagram often shows a carousel starting on slide 2, so this one works as a cover on its own. No photo needed. Edit both [bracket] lines.</a:t>
             </a:r>
           </a:p>
         </p:txBody>
@@ -999,7 +999,7 @@
           <a:lstStyle/>
           <a:p>
             <a:r>
-              <a:t>Slide 8. Swap in a second photo of you (head near the top, under the crown). Type your keyword.</a:t>
+              <a:t>Slide 8. Swap in a second photo of you (head near the top, under the crown). Type your keyword. Caption to start from (CTA in the first two sentences, 3 hashtags): Comment [KEYWORD] and I will send you [the link]. [One line of real context: who it helps or how you use it.] #[tag] #[tag] #[tag]</a:t>
             </a:r>
           </a:p>
         </p:txBody>
@@ -4224,7 +4224,7 @@
       </p:pic>
       <p:pic>
         <p:nvPicPr>
-          <p:cNvPr id="9" name="underline" descr="006.png"/>
+          <p:cNvPr id="9" name="sparkle" descr="006.png"/>
           <p:cNvPicPr>
             <a:picLocks noChangeAspect="1"/>
           </p:cNvPicPr>
@@ -4237,9 +4237,9 @@
           </a:stretch>
         </p:blipFill>
         <p:spPr>
-          <a:xfrm rot="180000">
-            <a:off x="5667375" y="12734925"/>
-            <a:ext cx="3143250" cy="247650"/>
+          <a:xfrm>
+            <a:off x="9001125" y="10001250"/>
+            <a:ext cx="1143000" cy="1333500"/>
           </a:xfrm>
           <a:prstGeom prst="rect">
             <a:avLst/>
@@ -4262,30 +4262,6 @@
         </p:blipFill>
         <p:spPr>
           <a:xfrm>
-            <a:off x="8953500" y="9853612"/>
-            <a:ext cx="1238250" cy="1628775"/>
-          </a:xfrm>
-          <a:prstGeom prst="rect">
-            <a:avLst/>
-          </a:prstGeom>
-        </p:spPr>
-      </p:pic>
-      <p:pic>
-        <p:nvPicPr>
-          <p:cNvPr id="11" name="sparkle" descr="008.png"/>
-          <p:cNvPicPr>
-            <a:picLocks noChangeAspect="1"/>
-          </p:cNvPicPr>
-          <p:nvPr/>
-        </p:nvPicPr>
-        <p:blipFill>
-          <a:blip r:embed="rId10"/>
-          <a:stretch>
-            <a:fillRect/>
-          </a:stretch>
-        </p:blipFill>
-        <p:spPr>
-          <a:xfrm>
             <a:off x="381000" y="8577262"/>
             <a:ext cx="857250" cy="1133475"/>
           </a:xfrm>
@@ -4296,7 +4272,7 @@
       </p:pic>
       <p:sp>
         <p:nvSpPr>
-          <p:cNvPr id="12" name="GUIDE (delete)"/>
+          <p:cNvPr id="11" name="GUIDE (delete)"/>
           <p:cNvSpPr/>
           <p:nvPr/>
         </p:nvSpPr>
@@ -4395,7 +4371,7 @@
       </p:pic>
       <p:pic>
         <p:nvPicPr>
-          <p:cNvPr id="3" name="burst" descr="009.png"/>
+          <p:cNvPr id="3" name="burst" descr="008.png"/>
           <p:cNvPicPr>
             <a:picLocks noChangeAspect="1"/>
           </p:cNvPicPr>
@@ -4409,7 +4385,7 @@
         </p:blipFill>
         <p:spPr>
           <a:xfrm>
-            <a:off x="1047750" y="4233862"/>
+            <a:off x="1047750" y="4519612"/>
             <a:ext cx="8191500" cy="7153275"/>
           </a:xfrm>
           <a:prstGeom prst="rect">
@@ -4419,7 +4395,7 @@
       </p:pic>
       <p:pic>
         <p:nvPicPr>
-          <p:cNvPr id="4" name="alarm clock" descr="010.png"/>
+          <p:cNvPr id="4" name="alarm clock" descr="009.png"/>
           <p:cNvPicPr>
             <a:picLocks noChangeAspect="1"/>
           </p:cNvPicPr>
@@ -4433,7 +4409,7 @@
         </p:blipFill>
         <p:spPr>
           <a:xfrm rot="21240000">
-            <a:off x="1943100" y="3724275"/>
+            <a:off x="1943100" y="4010025"/>
             <a:ext cx="6400800" cy="8172450"/>
           </a:xfrm>
           <a:prstGeom prst="rect">
@@ -4443,7 +4419,7 @@
       </p:pic>
       <p:pic>
         <p:nvPicPr>
-          <p:cNvPr id="5" name="paper ball" descr="011.png"/>
+          <p:cNvPr id="5" name="paper ball" descr="010.png"/>
           <p:cNvPicPr>
             <a:picLocks noChangeAspect="1"/>
           </p:cNvPicPr>
@@ -4457,7 +4433,7 @@
         </p:blipFill>
         <p:spPr>
           <a:xfrm>
-            <a:off x="347852" y="4949104"/>
+            <a:off x="347852" y="5588241"/>
             <a:ext cx="2609850" cy="2409825"/>
           </a:xfrm>
           <a:prstGeom prst="rect">
@@ -4467,7 +4443,7 @@
       </p:pic>
       <p:pic>
         <p:nvPicPr>
-          <p:cNvPr id="6" name="paper ball" descr="012.png"/>
+          <p:cNvPr id="6" name="paper ball" descr="011.png"/>
           <p:cNvPicPr>
             <a:picLocks noChangeAspect="1"/>
           </p:cNvPicPr>
@@ -4481,7 +4457,7 @@
         </p:blipFill>
         <p:spPr>
           <a:xfrm rot="20100000">
-            <a:off x="3872968" y="2050486"/>
+            <a:off x="3872968" y="3002696"/>
             <a:ext cx="2800350" cy="2571750"/>
           </a:xfrm>
           <a:prstGeom prst="rect">
@@ -4491,7 +4467,7 @@
       </p:pic>
       <p:pic>
         <p:nvPicPr>
-          <p:cNvPr id="7" name="paper ball" descr="013.png"/>
+          <p:cNvPr id="7" name="paper ball" descr="012.png"/>
           <p:cNvPicPr>
             <a:picLocks noChangeAspect="1"/>
           </p:cNvPicPr>
@@ -4505,7 +4481,7 @@
         </p:blipFill>
         <p:spPr>
           <a:xfrm rot="18600000">
-            <a:off x="7218922" y="5066949"/>
+            <a:off x="7218922" y="5674472"/>
             <a:ext cx="2990850" cy="2743200"/>
           </a:xfrm>
           <a:prstGeom prst="rect">
@@ -4515,7 +4491,7 @@
       </p:pic>
       <p:pic>
         <p:nvPicPr>
-          <p:cNvPr id="8" name="paper ball" descr="011.png"/>
+          <p:cNvPr id="8" name="paper ball" descr="010.png"/>
           <p:cNvPicPr>
             <a:picLocks noChangeAspect="1"/>
           </p:cNvPicPr>
@@ -4529,7 +4505,7 @@
         </p:blipFill>
         <p:spPr>
           <a:xfrm rot="17100000">
-            <a:off x="5915837" y="9968550"/>
+            <a:off x="5915837" y="10049971"/>
             <a:ext cx="2609850" cy="2409825"/>
           </a:xfrm>
           <a:prstGeom prst="rect">
@@ -4539,7 +4515,7 @@
       </p:pic>
       <p:pic>
         <p:nvPicPr>
-          <p:cNvPr id="9" name="paper ball" descr="012.png"/>
+          <p:cNvPr id="9" name="paper ball" descr="011.png"/>
           <p:cNvPicPr>
             <a:picLocks noChangeAspect="1"/>
           </p:cNvPicPr>
@@ -4553,7 +4529,7 @@
         </p:blipFill>
         <p:spPr>
           <a:xfrm rot="15600000">
-            <a:off x="1456297" y="9711736"/>
+            <a:off x="1456297" y="9812696"/>
             <a:ext cx="2800350" cy="2571750"/>
           </a:xfrm>
           <a:prstGeom prst="rect">
@@ -4563,14 +4539,14 @@
       </p:pic>
       <p:sp>
         <p:nvSpPr>
-          <p:cNvPr id="10" name="TEXT: [late. again.]"/>
+          <p:cNvPr id="10" name="TEXT: [always running late?]"/>
           <p:cNvSpPr/>
           <p:nvPr/>
         </p:nvSpPr>
         <p:spPr>
-          <a:xfrm rot="180000">
-            <a:off x="2500312" y="1543050"/>
-            <a:ext cx="5286375" cy="1104900"/>
+          <a:xfrm rot="120000">
+            <a:off x="1824038" y="638175"/>
+            <a:ext cx="7781925" cy="2343150"/>
           </a:xfrm>
           <a:prstGeom prst="rect">
             <a:avLst/>
@@ -4598,26 +4574,123 @@
           </a:fontRef>
         </p:style>
         <p:txBody>
-          <a:bodyPr rtlCol="0" anchor="ctr" wrap="none" lIns="213360" rIns="213360" tIns="91440" bIns="91440"/>
+          <a:bodyPr rtlCol="0" anchor="ctr" wrap="none" lIns="245364" rIns="245364" tIns="105156" bIns="105156"/>
           <a:lstStyle/>
           <a:p>
-            <a:pPr algn="ctr">
+            <a:pPr algn="r">
               <a:lnSpc>
-                <a:spcPts val="7319"/>
+                <a:spcPts val="8418"/>
               </a:lnSpc>
             </a:pPr>
             <a:r>
-              <a:rPr b="1" sz="6000">
+              <a:rPr b="1" sz="6900">
                 <a:solidFill>
                   <a:srgbClr val="181716"/>
                 </a:solidFill>
                 <a:latin typeface="Montserrat"/>
               </a:rPr>
-              <a:t>[late. again.]</a:t>
-            </a:r>
-          </a:p>
-        </p:txBody>
-      </p:sp>
+              <a:t>[always running</a:t>
+            </a:r>
+          </a:p>
+          <a:p>
+            <a:pPr algn="r">
+              <a:lnSpc>
+                <a:spcPts val="8418"/>
+              </a:lnSpc>
+            </a:pPr>
+            <a:r>
+              <a:rPr b="1" sz="6900">
+                <a:solidFill>
+                  <a:srgbClr val="181716"/>
+                </a:solidFill>
+                <a:latin typeface="Montserrat"/>
+              </a:rPr>
+              <a:t>late?]</a:t>
+            </a:r>
+          </a:p>
+        </p:txBody>
+      </p:sp>
+      <p:sp>
+        <p:nvSpPr>
+          <p:cNvPr id="11" name="TEXT: [here's what helps]"/>
+          <p:cNvSpPr/>
+          <p:nvPr/>
+        </p:nvSpPr>
+        <p:spPr>
+          <a:xfrm rot="120000">
+            <a:off x="519112" y="12144375"/>
+            <a:ext cx="6200775" cy="857250"/>
+          </a:xfrm>
+          <a:prstGeom prst="rect">
+            <a:avLst/>
+          </a:prstGeom>
+          <a:solidFill>
+            <a:srgbClr val="FFFFFF"/>
+          </a:solidFill>
+          <a:ln>
+            <a:noFill/>
+          </a:ln>
+          <a:effectLst/>
+        </p:spPr>
+        <p:style>
+          <a:lnRef idx="1">
+            <a:schemeClr val="accent1"/>
+          </a:lnRef>
+          <a:fillRef idx="3">
+            <a:schemeClr val="accent1"/>
+          </a:fillRef>
+          <a:effectRef idx="2">
+            <a:schemeClr val="accent1"/>
+          </a:effectRef>
+          <a:fontRef idx="minor">
+            <a:schemeClr val="lt1"/>
+          </a:fontRef>
+        </p:style>
+        <p:txBody>
+          <a:bodyPr rtlCol="0" anchor="ctr" wrap="none" lIns="165354" rIns="165354" tIns="70866" bIns="70866"/>
+          <a:lstStyle/>
+          <a:p>
+            <a:pPr algn="l">
+              <a:lnSpc>
+                <a:spcPts val="5673"/>
+              </a:lnSpc>
+            </a:pPr>
+            <a:r>
+              <a:rPr b="1" sz="4650">
+                <a:solidFill>
+                  <a:srgbClr val="181716"/>
+                </a:solidFill>
+                <a:latin typeface="Montserrat"/>
+              </a:rPr>
+              <a:t>[here's what helps]</a:t>
+            </a:r>
+          </a:p>
+        </p:txBody>
+      </p:sp>
+      <p:pic>
+        <p:nvPicPr>
+          <p:cNvPr id="12" name="arrow" descr="015.png"/>
+          <p:cNvPicPr>
+            <a:picLocks noChangeAspect="1"/>
+          </p:cNvPicPr>
+          <p:nvPr/>
+        </p:nvPicPr>
+        <p:blipFill>
+          <a:blip r:embed="rId8"/>
+          <a:stretch>
+            <a:fillRect/>
+          </a:stretch>
+        </p:blipFill>
+        <p:spPr>
+          <a:xfrm rot="120000">
+            <a:off x="6810375" y="12272962"/>
+            <a:ext cx="1619250" cy="504825"/>
+          </a:xfrm>
+          <a:prstGeom prst="rect">
+            <a:avLst/>
+          </a:prstGeom>
+        </p:spPr>
+      </p:pic>
     </p:spTree>
   </p:cSld>
   <p:clrMapOvr>
@@ -4710,7 +4783,7 @@
       </p:pic>
       <p:pic>
         <p:nvPicPr>
-          <p:cNvPr id="5" name="paper ball" descr="012.png"/>
+          <p:cNvPr id="5" name="paper ball" descr="011.png"/>
           <p:cNvPicPr>
             <a:picLocks noChangeAspect="1"/>
           </p:cNvPicPr>
@@ -4734,7 +4807,7 @@
       </p:pic>
       <p:pic>
         <p:nvPicPr>
-          <p:cNvPr id="6" name="paper ball" descr="011.png"/>
+          <p:cNvPr id="6" name="paper ball" descr="010.png"/>
           <p:cNvPicPr>
             <a:picLocks noChangeAspect="1"/>
           </p:cNvPicPr>
@@ -4764,7 +4837,7 @@
         </p:nvSpPr>
         <p:spPr>
           <a:xfrm rot="21420000">
-            <a:off x="2466975" y="1466850"/>
+            <a:off x="1323975" y="1466850"/>
             <a:ext cx="5353050" cy="1828800"/>
           </a:xfrm>
           <a:prstGeom prst="rect">
@@ -4796,7 +4869,7 @@
           <a:bodyPr rtlCol="0" anchor="ctr" wrap="none" lIns="192024" rIns="192024" tIns="82296" bIns="82296"/>
           <a:lstStyle/>
           <a:p>
-            <a:pPr algn="ctr">
+            <a:pPr algn="l">
               <a:lnSpc>
                 <a:spcPts val="6588"/>
               </a:lnSpc>
@@ -4812,7 +4885,7 @@
             </a:r>
           </a:p>
           <a:p>
-            <a:pPr algn="ctr">
+            <a:pPr algn="l">
               <a:lnSpc>
                 <a:spcPts val="6588"/>
               </a:lnSpc>
@@ -4930,7 +5003,7 @@
       </p:pic>
       <p:pic>
         <p:nvPicPr>
-          <p:cNvPr id="3" name="torn paper" descr="020.png"/>
+          <p:cNvPr id="3" name="PHOTO: Your product (fills the page)" descr="020.png"/>
           <p:cNvPicPr>
             <a:picLocks noChangeAspect="1"/>
           </p:cNvPicPr>
@@ -4943,9 +5016,9 @@
           </a:stretch>
         </p:blipFill>
         <p:spPr>
-          <a:xfrm rot="21480000">
-            <a:off x="1257300" y="4210050"/>
-            <a:ext cx="8153400" cy="9296400"/>
+          <a:xfrm>
+            <a:off x="0" y="0"/>
+            <a:ext cx="10287000" cy="13716000"/>
           </a:xfrm>
           <a:prstGeom prst="rect">
             <a:avLst/>
@@ -4954,7 +5027,7 @@
       </p:pic>
       <p:pic>
         <p:nvPicPr>
-          <p:cNvPr id="4" name="PHOTO: Your product" descr="021.png"/>
+          <p:cNvPr id="4" name="torn notebook strip" descr="021.png"/>
           <p:cNvPicPr>
             <a:picLocks noChangeAspect="1"/>
           </p:cNvPicPr>
@@ -4967,9 +5040,9 @@
           </a:stretch>
         </p:blipFill>
         <p:spPr>
-          <a:xfrm rot="21480000">
-            <a:off x="1905000" y="4857750"/>
-            <a:ext cx="6858000" cy="8001000"/>
+          <a:xfrm>
+            <a:off x="-381000" y="-381000"/>
+            <a:ext cx="11049000" cy="5524500"/>
           </a:xfrm>
           <a:prstGeom prst="rect">
             <a:avLst/>
@@ -4992,7 +5065,7 @@
         </p:blipFill>
         <p:spPr>
           <a:xfrm>
-            <a:off x="2628900" y="919162"/>
+            <a:off x="2628900" y="681038"/>
             <a:ext cx="5029200" cy="1971675"/>
           </a:xfrm>
           <a:prstGeom prst="rect">
@@ -5008,7 +5081,7 @@
         </p:nvSpPr>
         <p:spPr>
           <a:xfrm rot="120000">
-            <a:off x="1576388" y="3095625"/>
+            <a:off x="1576388" y="2809875"/>
             <a:ext cx="7134225" cy="1047750"/>
           </a:xfrm>
           <a:prstGeom prst="rect">
@@ -5073,8 +5146,8 @@
         </p:blipFill>
         <p:spPr>
           <a:xfrm>
-            <a:off x="381000" y="5024438"/>
-            <a:ext cx="2095500" cy="1381125"/>
+            <a:off x="666750" y="5086350"/>
+            <a:ext cx="1905000" cy="1257300"/>
           </a:xfrm>
           <a:prstGeom prst="rect">
             <a:avLst/>
@@ -5097,7 +5170,7 @@
         </p:blipFill>
         <p:spPr>
           <a:xfrm rot="20400000">
-            <a:off x="6981825" y="3662362"/>
+            <a:off x="6981825" y="3471862"/>
             <a:ext cx="3181350" cy="2581275"/>
           </a:xfrm>
           <a:prstGeom prst="rect">
@@ -5293,7 +5366,7 @@
       </p:pic>
       <p:pic>
         <p:nvPicPr>
-          <p:cNvPr id="9" name="sparkle" descr="008.png"/>
+          <p:cNvPr id="9" name="sparkle" descr="007.png"/>
           <p:cNvPicPr>
             <a:picLocks noChangeAspect="1"/>
           </p:cNvPicPr>
@@ -5355,7 +5428,7 @@
           <a:bodyPr rtlCol="0" anchor="ctr" wrap="none" lIns="154686" rIns="154686" tIns="66294" bIns="66294"/>
           <a:lstStyle/>
           <a:p>
-            <a:pPr algn="ctr">
+            <a:pPr algn="l">
               <a:lnSpc>
                 <a:spcPts val="5307"/>
               </a:lnSpc>
@@ -5371,7 +5444,7 @@
             </a:r>
           </a:p>
           <a:p>
-            <a:pPr algn="ctr">
+            <a:pPr algn="l">
               <a:lnSpc>
                 <a:spcPts val="5307"/>
               </a:lnSpc>
@@ -5432,7 +5505,7 @@
       </p:pic>
       <p:pic>
         <p:nvPicPr>
-          <p:cNvPr id="3" name="made for" descr="032.png"/>
+          <p:cNvPr id="3" name="mug" descr="032.png"/>
           <p:cNvPicPr>
             <a:picLocks noChangeAspect="1"/>
           </p:cNvPicPr>
@@ -5445,9 +5518,9 @@
           </a:stretch>
         </p:blipFill>
         <p:spPr>
-          <a:xfrm rot="120000">
-            <a:off x="1766888" y="933450"/>
-            <a:ext cx="6753225" cy="2133600"/>
+          <a:xfrm rot="21240000">
+            <a:off x="6086475" y="9620250"/>
+            <a:ext cx="3448050" cy="3238500"/>
           </a:xfrm>
           <a:prstGeom prst="rect">
             <a:avLst/>
@@ -5456,7 +5529,7 @@
       </p:pic>
       <p:pic>
         <p:nvPicPr>
-          <p:cNvPr id="4" name="mug" descr="033.png"/>
+          <p:cNvPr id="4" name="sticky note" descr="033.png"/>
           <p:cNvPicPr>
             <a:picLocks noChangeAspect="1"/>
           </p:cNvPicPr>
@@ -5469,9 +5542,9 @@
           </a:stretch>
         </p:blipFill>
         <p:spPr>
-          <a:xfrm rot="21240000">
-            <a:off x="6276975" y="10096500"/>
-            <a:ext cx="3448050" cy="3238500"/>
+          <a:xfrm rot="360000">
+            <a:off x="590550" y="1381125"/>
+            <a:ext cx="4533900" cy="4476750"/>
           </a:xfrm>
           <a:prstGeom prst="rect">
             <a:avLst/>
@@ -5493,8 +5566,8 @@
           </a:stretch>
         </p:blipFill>
         <p:spPr>
-          <a:xfrm rot="360000">
-            <a:off x="590550" y="3476625"/>
+          <a:xfrm rot="21300000">
+            <a:off x="4972050" y="4429125"/>
             <a:ext cx="4533900" cy="4476750"/>
           </a:xfrm>
           <a:prstGeom prst="rect">
@@ -5517,8 +5590,8 @@
           </a:stretch>
         </p:blipFill>
         <p:spPr>
-          <a:xfrm rot="21300000">
-            <a:off x="5067300" y="5667375"/>
+          <a:xfrm rot="180000">
+            <a:off x="876300" y="7572375"/>
             <a:ext cx="4533900" cy="4476750"/>
           </a:xfrm>
           <a:prstGeom prst="rect">
@@ -5526,39 +5599,15 @@
           </a:prstGeom>
         </p:spPr>
       </p:pic>
-      <p:pic>
-        <p:nvPicPr>
-          <p:cNvPr id="7" name="sticky note" descr="036.png"/>
-          <p:cNvPicPr>
-            <a:picLocks noChangeAspect="1"/>
-          </p:cNvPicPr>
-          <p:nvPr/>
-        </p:nvPicPr>
-        <p:blipFill>
-          <a:blip r:embed="rId7"/>
-          <a:stretch>
-            <a:fillRect/>
-          </a:stretch>
-        </p:blipFill>
-        <p:spPr>
-          <a:xfrm rot="180000">
-            <a:off x="781050" y="8239125"/>
-            <a:ext cx="4533900" cy="4476750"/>
-          </a:xfrm>
-          <a:prstGeom prst="rect">
-            <a:avLst/>
-          </a:prstGeom>
-        </p:spPr>
-      </p:pic>
-      <p:sp>
-        <p:nvSpPr>
-          <p:cNvPr id="8" name="TEXT: for the [6am crowd]"/>
+      <p:sp>
+        <p:nvSpPr>
+          <p:cNvPr id="7" name="TEXT: for the [6am crowd]"/>
           <p:cNvSpPr/>
           <p:nvPr/>
         </p:nvSpPr>
         <p:spPr>
           <a:xfrm rot="360000">
-            <a:off x="1125859" y="5285227"/>
+            <a:off x="1125859" y="3189727"/>
             <a:ext cx="3419475" cy="1276350"/>
           </a:xfrm>
           <a:prstGeom prst="rect">
@@ -5588,7 +5637,7 @@
           <a:bodyPr rtlCol="0" anchor="ctr" wrap="none" lIns="133350" rIns="133350" tIns="57150" bIns="57150"/>
           <a:lstStyle/>
           <a:p>
-            <a:pPr algn="ctr">
+            <a:pPr algn="l">
               <a:lnSpc>
                 <a:spcPts val="4575"/>
               </a:lnSpc>
@@ -5604,7 +5653,7 @@
             </a:r>
           </a:p>
           <a:p>
-            <a:pPr algn="ctr">
+            <a:pPr algn="l">
               <a:lnSpc>
                 <a:spcPts val="4575"/>
               </a:lnSpc>
@@ -5623,13 +5672,13 @@
       </p:sp>
       <p:sp>
         <p:nvSpPr>
-          <p:cNvPr id="9" name="TEXT: for the [dog mums]"/>
+          <p:cNvPr id="8" name="TEXT: for the [dog mums]"/>
           <p:cNvSpPr/>
           <p:nvPr/>
         </p:nvSpPr>
         <p:spPr>
           <a:xfrm rot="21300000">
-            <a:off x="5714213" y="7476328"/>
+            <a:off x="5618963" y="6238078"/>
             <a:ext cx="3276600" cy="1276350"/>
           </a:xfrm>
           <a:prstGeom prst="rect">
@@ -5659,7 +5708,7 @@
           <a:bodyPr rtlCol="0" anchor="ctr" wrap="none" lIns="133350" rIns="133350" tIns="57150" bIns="57150"/>
           <a:lstStyle/>
           <a:p>
-            <a:pPr algn="ctr">
+            <a:pPr algn="l">
               <a:lnSpc>
                 <a:spcPts val="4575"/>
               </a:lnSpc>
@@ -5675,7 +5724,7 @@
             </a:r>
           </a:p>
           <a:p>
-            <a:pPr algn="ctr">
+            <a:pPr algn="l">
               <a:lnSpc>
                 <a:spcPts val="4575"/>
               </a:lnSpc>
@@ -5694,13 +5743,13 @@
       </p:sp>
       <p:sp>
         <p:nvSpPr>
-          <p:cNvPr id="10" name="TEXT: for the [busy mums]"/>
+          <p:cNvPr id="9" name="TEXT: for the [busy mums]"/>
           <p:cNvSpPr/>
           <p:nvPr/>
         </p:nvSpPr>
         <p:spPr>
           <a:xfrm rot="180000">
-            <a:off x="1284433" y="10048588"/>
+            <a:off x="1379683" y="9381838"/>
             <a:ext cx="3505200" cy="1276350"/>
           </a:xfrm>
           <a:prstGeom prst="rect">
@@ -5730,7 +5779,7 @@
           <a:bodyPr rtlCol="0" anchor="ctr" wrap="none" lIns="133350" rIns="133350" tIns="57150" bIns="57150"/>
           <a:lstStyle/>
           <a:p>
-            <a:pPr algn="ctr">
+            <a:pPr algn="l">
               <a:lnSpc>
                 <a:spcPts val="4575"/>
               </a:lnSpc>
@@ -5746,7 +5795,7 @@
             </a:r>
           </a:p>
           <a:p>
-            <a:pPr algn="ctr">
+            <a:pPr algn="l">
               <a:lnSpc>
                 <a:spcPts val="4575"/>
               </a:lnSpc>
@@ -5807,7 +5856,7 @@
       </p:pic>
       <p:pic>
         <p:nvPicPr>
-          <p:cNvPr id="3" name="burst" descr="037.png"/>
+          <p:cNvPr id="3" name="burst" descr="036.png"/>
           <p:cNvPicPr>
             <a:picLocks noChangeAspect="1"/>
           </p:cNvPicPr>
@@ -5831,7 +5880,7 @@
       </p:pic>
       <p:pic>
         <p:nvPicPr>
-          <p:cNvPr id="4" name="phone" descr="038.png"/>
+          <p:cNvPr id="4" name="phone" descr="037.png"/>
           <p:cNvPicPr>
             <a:picLocks noChangeAspect="1"/>
           </p:cNvPicPr>
@@ -5855,7 +5904,7 @@
       </p:pic>
       <p:pic>
         <p:nvPicPr>
-          <p:cNvPr id="5" name="PHOTO: Your shop or listing (screenshot)" descr="039.png"/>
+          <p:cNvPr id="5" name="PHOTO: Your shop or listing (screenshot)" descr="038.png"/>
           <p:cNvPicPr>
             <a:picLocks noChangeAspect="1"/>
           </p:cNvPicPr>
@@ -5879,7 +5928,7 @@
       </p:pic>
       <p:pic>
         <p:nvPicPr>
-          <p:cNvPr id="6" name="butterfly" descr="040.png"/>
+          <p:cNvPr id="6" name="butterfly" descr="039.png"/>
           <p:cNvPicPr>
             <a:picLocks noChangeAspect="1"/>
           </p:cNvPicPr>
@@ -6002,7 +6051,7 @@
       </p:pic>
       <p:pic>
         <p:nvPicPr>
-          <p:cNvPr id="3" name="torn paper" descr="041.png"/>
+          <p:cNvPr id="3" name="torn paper" descr="040.png"/>
           <p:cNvPicPr>
             <a:picLocks noChangeAspect="1"/>
           </p:cNvPicPr>
@@ -6026,7 +6075,7 @@
       </p:pic>
       <p:pic>
         <p:nvPicPr>
-          <p:cNvPr id="4" name="PHOTO: You again (head near the top)" descr="042.png"/>
+          <p:cNvPr id="4" name="PHOTO: You again (head near the top)" descr="041.png"/>
           <p:cNvPicPr>
             <a:picLocks noChangeAspect="1"/>
           </p:cNvPicPr>
@@ -6050,7 +6099,7 @@
       </p:pic>
       <p:pic>
         <p:nvPicPr>
-          <p:cNvPr id="5" name="butterfly" descr="043.png"/>
+          <p:cNvPr id="5" name="butterfly" descr="042.png"/>
           <p:cNvPicPr>
             <a:picLocks noChangeAspect="1"/>
           </p:cNvPicPr>
@@ -6074,7 +6123,7 @@
       </p:pic>
       <p:pic>
         <p:nvPicPr>
-          <p:cNvPr id="6" name="butterfly" descr="044.png"/>
+          <p:cNvPr id="6" name="butterfly" descr="043.png"/>
           <p:cNvPicPr>
             <a:picLocks noChangeAspect="1"/>
           </p:cNvPicPr>
@@ -6098,7 +6147,7 @@
       </p:pic>
       <p:pic>
         <p:nvPicPr>
-          <p:cNvPr id="7" name="butterfly" descr="040.png"/>
+          <p:cNvPr id="7" name="butterfly" descr="039.png"/>
           <p:cNvPicPr>
             <a:picLocks noChangeAspect="1"/>
           </p:cNvPicPr>
@@ -6122,7 +6171,7 @@
       </p:pic>
       <p:pic>
         <p:nvPicPr>
-          <p:cNvPr id="8" name="butterfly" descr="043.png"/>
+          <p:cNvPr id="8" name="butterfly" descr="042.png"/>
           <p:cNvPicPr>
             <a:picLocks noChangeAspect="1"/>
           </p:cNvPicPr>
@@ -6146,7 +6195,7 @@
       </p:pic>
       <p:pic>
         <p:nvPicPr>
-          <p:cNvPr id="9" name="butterfly" descr="044.png"/>
+          <p:cNvPr id="9" name="butterfly" descr="043.png"/>
           <p:cNvPicPr>
             <a:picLocks noChangeAspect="1"/>
           </p:cNvPicPr>
@@ -6170,7 +6219,7 @@
       </p:pic>
       <p:pic>
         <p:nvPicPr>
-          <p:cNvPr id="10" name="butterfly" descr="040.png"/>
+          <p:cNvPr id="10" name="butterfly" descr="039.png"/>
           <p:cNvPicPr>
             <a:picLocks noChangeAspect="1"/>
           </p:cNvPicPr>
@@ -6251,7 +6300,7 @@
       </p:sp>
       <p:pic>
         <p:nvPicPr>
-          <p:cNvPr id="12" name="Comment" descr="049.png"/>
+          <p:cNvPr id="12" name="Comment" descr="048.png"/>
           <p:cNvPicPr>
             <a:picLocks noChangeAspect="1"/>
           </p:cNvPicPr>
@@ -6334,7 +6383,7 @@
       </p:sp>
       <p:pic>
         <p:nvPicPr>
-          <p:cNvPr id="14" name="sparkle" descr="050.png"/>
+          <p:cNvPr id="14" name="sparkle" descr="049.png"/>
           <p:cNvPicPr>
             <a:picLocks noChangeAspect="1"/>
           </p:cNvPicPr>

</xml_diff>

<commit_message>
Reel Template Packs: matching carousels for 08, 10, 12, 20, 22, 23 (shared kit + one recipe each, carousel rules applied); upload zips now include '3 Matching carousel' with a Canva how-to
Co-Authored-By: Claude Opus 5.5 <noreply@anthropic.com>
</commit_message>
<xml_diff>
--- a/automation/reel-template-pack/09-who-its-for/carousel/Template 09 - Who its for - Carousel.pptx
+++ b/automation/reel-template-pack/09-who-its-for/carousel/Template 09 - Who its for - Carousel.pptx
@@ -4007,7 +4007,7 @@
       <p:grpSpPr/>
       <p:pic>
         <p:nvPicPr>
-          <p:cNvPr id="2" name="paper (background)" descr="paper.jpg"/>
+          <p:cNvPr id="2" name="background" descr="bg0.jpg"/>
           <p:cNvPicPr>
             <a:picLocks noChangeAspect="1"/>
           </p:cNvPicPr>
@@ -4190,8 +4190,8 @@
         </p:blipFill>
         <p:spPr>
           <a:xfrm rot="180000">
-            <a:off x="1690688" y="9620250"/>
-            <a:ext cx="4238625" cy="1714500"/>
+            <a:off x="1647825" y="9620250"/>
+            <a:ext cx="4324350" cy="1714500"/>
           </a:xfrm>
           <a:prstGeom prst="rect">
             <a:avLst/>
@@ -4214,8 +4214,8 @@
         </p:blipFill>
         <p:spPr>
           <a:xfrm rot="180000">
-            <a:off x="2314575" y="10796588"/>
-            <a:ext cx="6800850" cy="2124075"/>
+            <a:off x="2262188" y="10796588"/>
+            <a:ext cx="6905625" cy="2124075"/>
           </a:xfrm>
           <a:prstGeom prst="rect">
             <a:avLst/>
@@ -4278,7 +4278,7 @@
         </p:nvSpPr>
         <p:spPr>
           <a:xfrm>
-            <a:off x="1352550" y="13015912"/>
+            <a:off x="1352550" y="13063538"/>
             <a:ext cx="7581900" cy="352425"/>
           </a:xfrm>
           <a:prstGeom prst="rect">
@@ -4347,7 +4347,7 @@
       <p:grpSpPr/>
       <p:pic>
         <p:nvPicPr>
-          <p:cNvPr id="2" name="paper (background)" descr="paper.jpg"/>
+          <p:cNvPr id="2" name="background" descr="bg0.jpg"/>
           <p:cNvPicPr>
             <a:picLocks noChangeAspect="1"/>
           </p:cNvPicPr>
@@ -4711,7 +4711,7 @@
       <p:grpSpPr/>
       <p:pic>
         <p:nvPicPr>
-          <p:cNvPr id="2" name="paper (background)" descr="paper.jpg"/>
+          <p:cNvPr id="2" name="background" descr="bg0.jpg"/>
           <p:cNvPicPr>
             <a:picLocks noChangeAspect="1"/>
           </p:cNvPicPr>
@@ -4910,7 +4910,7 @@
         </p:nvSpPr>
         <p:spPr>
           <a:xfrm>
-            <a:off x="2371725" y="13015912"/>
+            <a:off x="2371725" y="13063538"/>
             <a:ext cx="5543550" cy="352425"/>
           </a:xfrm>
           <a:prstGeom prst="rect">
@@ -4979,7 +4979,7 @@
       <p:grpSpPr/>
       <p:pic>
         <p:nvPicPr>
-          <p:cNvPr id="2" name="paper (background)" descr="paper.jpg"/>
+          <p:cNvPr id="2" name="background" descr="bg0.jpg"/>
           <p:cNvPicPr>
             <a:picLocks noChangeAspect="1"/>
           </p:cNvPicPr>
@@ -5198,7 +5198,7 @@
       <p:grpSpPr/>
       <p:pic>
         <p:nvPicPr>
-          <p:cNvPr id="2" name="paper (background)" descr="paper.jpg"/>
+          <p:cNvPr id="2" name="background" descr="bg0.jpg"/>
           <p:cNvPicPr>
             <a:picLocks noChangeAspect="1"/>
           </p:cNvPicPr>
@@ -5260,8 +5260,8 @@
         </p:blipFill>
         <p:spPr>
           <a:xfrm>
-            <a:off x="5905500" y="10477500"/>
-            <a:ext cx="2000250" cy="3333750"/>
+            <a:off x="5334000" y="10477500"/>
+            <a:ext cx="3143250" cy="3333750"/>
           </a:xfrm>
           <a:prstGeom prst="rect">
             <a:avLst/>
@@ -5481,7 +5481,7 @@
       <p:grpSpPr/>
       <p:pic>
         <p:nvPicPr>
-          <p:cNvPr id="2" name="paper (background)" descr="paper.jpg"/>
+          <p:cNvPr id="2" name="background" descr="bg0.jpg"/>
           <p:cNvPicPr>
             <a:picLocks noChangeAspect="1"/>
           </p:cNvPicPr>
@@ -5832,7 +5832,7 @@
       <p:grpSpPr/>
       <p:pic>
         <p:nvPicPr>
-          <p:cNvPr id="2" name="paper (background)" descr="paper.jpg"/>
+          <p:cNvPr id="2" name="background" descr="bg0.jpg"/>
           <p:cNvPicPr>
             <a:picLocks noChangeAspect="1"/>
           </p:cNvPicPr>
@@ -5918,8 +5918,8 @@
         </p:blipFill>
         <p:spPr>
           <a:xfrm>
-            <a:off x="3752850" y="4071938"/>
-            <a:ext cx="3152775" cy="6905625"/>
+            <a:off x="3762375" y="4081462"/>
+            <a:ext cx="3133725" cy="6886575"/>
           </a:xfrm>
           <a:prstGeom prst="rect">
             <a:avLst/>
@@ -6027,7 +6027,7 @@
       <p:grpSpPr/>
       <p:pic>
         <p:nvPicPr>
-          <p:cNvPr id="2" name="paper (background)" descr="paper.jpg"/>
+          <p:cNvPr id="2" name="background" descr="bg0.jpg"/>
           <p:cNvPicPr>
             <a:picLocks noChangeAspect="1"/>
           </p:cNvPicPr>

</xml_diff>